<commit_message>
Logistic regression: in-class exercise churn_exercise.qmd; deck and sample code updated
Co-Authored-By: Claude Opus 5.5 <noreply@anthropic.com>
Claude-Session: https://claude.ai/code/session_01TbrdxHn7W6FVXXnpqzNytd
</commit_message>
<xml_diff>
--- a/slides/logistic-regression-in-international-marketing_WT26-27.pptx
+++ b/slides/logistic-regression-in-international-marketing_WT26-27.pptx
@@ -36576,7 +36576,7 @@
                 </a:solidFill>
                 <a:latin typeface="Consolas"/>
               </a:rPr>
-              <a:t>sessions/01-foundations/logit_churn.qmd</a:t>
+              <a:t>sessions/01-foundations/churn_exercise.qmd</a:t>
             </a:r>
             <a:r>
               <a:rPr sz="1200" b="0" lang="en-GB">
@@ -36584,7 +36584,7 @@
                   <a:schemeClr val="tx1"/>
                 </a:solidFill>
               </a:rPr>
-              <a:t>  (section “Your turn”; simulated data)</a:t>
+              <a:t>  (code to reuse: logit_churn.qmd)</a:t>
             </a:r>
           </a:p>
         </p:txBody>

</xml_diff>

<commit_message>
Logistic regression: simpler session code and updated deck
Co-Authored-By: Claude Opus 5.5 <noreply@anthropic.com>
Claude-Session: https://claude.ai/code/session_01TbrdxHn7W6FVXXnpqzNytd
</commit_message>
<xml_diff>
--- a/slides/logistic-regression-in-international-marketing_WT26-27.pptx
+++ b/slides/logistic-regression-in-international-marketing_WT26-27.pptx
@@ -2241,7 +2241,7 @@
           <a:lstStyle/>
           <a:p>
             <a:r>
-              <a:t>polars reads the csv; to_pandas() hands the data to statsmodels, which Step 2 imports together with numpy, as in the earlier decks. The qmd sits in sessions/01-foundations, hence the path two folders up. group_by with maintain_order keeps the countries in the order of the file, and filter inside agg gives the churn rate of each contract type. The qmd computes two more columns, the share of month-to-month customers and mean satisfaction, and prints the table with great_tables. In Germany 26.4 % of month-to-month customers churn against 9.6 % on a 24-month contract; in Spain 46.6 % against 24.7 %.</a:t>
+              <a:t>polars reads the csv; to_pandas() hands the data to statsmodels, which Step 2 imports together with numpy, as in the earlier decks. The qmd sits in sessions/01-foundations, hence the path two folders up. group_by with maintain_order keeps the countries in the order of the file, and filter inside agg gives the churn rate of each contract type. The qmd then prints the customers per country and customer 47 of slide 4. In Germany 26.4 % of month-to-month customers churn against 9.6 % on a 24-month contract; in Spain 46.6 % against 24.7 %.</a:t>
             </a:r>
           </a:p>
         </p:txBody>
@@ -2311,7 +2311,7 @@
           <a:lstStyle/>
           <a:p>
             <a:r>
-              <a:t>smf.logit works like smf.ols: a formula, the data, fit; the coefficients are on the log-odds scale. get_margeff(dummy=True) gives average marginal effects in probability units and treats month-to-month as a 0/1 switch: +15.6 percentage points over all customers. ame() is a three-line helper defined in the qmd (Step 2): it predicts every customer once with monthly = 1 and once with 0 and averages the difference by country, here 12.4 pp in Germany and 20.1 pp in Spain. get_prediction gives the churn probability of a profile, month-to-month with a price rise, one complaint call and 12 months of tenure, with a 95 % interval: 35.1 % in Germany and 60.9 % in Spain. The pooled model forces one slope on all countries, which overstates the country gap; for comparisons use the country models of Part 3. Code: qmd Steps 2, 3 and 7.</a:t>
+              <a:t>smf.logit works like smf.ols: a formula, the data, fit; the coefficients are on the log-odds scale. get_margeff(dummy=True) gives average marginal effects in probability units and treats month-to-month as a 0/1 switch: +15.6 percentage points over all customers. ame() is a three-line helper defined in the qmd (Step 2): it predicts every customer once with monthly = 1 and once with 0 and averages the difference by country, here 12.4 pp in Germany and 20.1 pp in Spain. get_prediction gives the churn probability of a profile, month-to-month with a price rise, one complaint call and 12 months of tenure, with a 95 % interval: 35.1 % in Germany and 60.9 % in Spain. The pooled model forces one slope on all countries, which overstates the country gap; for comparisons use the country models of Part 3. Code: qmd Step 2.</a:t>
             </a:r>
           </a:p>
         </p:txBody>
@@ -2451,7 +2451,7 @@
           <a:lstStyle/>
           <a:p>
             <a:r>
-              <a:t>This is the code of qmd Steps 8 and 9, line for line. One uniform random number per customer with seed 1 sends 30 per cent to the test set, 3,284 customers. The model, the churn formula plus satisfaction and country dummies, is fitted on the training customers only and predicts the test customers. argsort(-p) sorts them from the highest predicted churn down; the first 10 per cent are the top decile, and their churn rate (59.5 %) divided by the overall rate (24.2 %) is the lift, 2.46. The qmd continues with the confusion matrix, the gains chart and the uplift of the offer pilot.</a:t>
+              <a:t>This is the code of qmd Step 3, line for line. One uniform random number per customer with seed 1 sends 30 per cent to the test set, 3,284 customers. The model, the churn formula plus satisfaction and country dummies, is fitted on the training customers only and predicts the test customers. argsort(-p) sorts them from the highest predicted churn down; the first 10 per cent are the top decile, and their churn rate (59.5 %) divided by the overall rate (24.2 %) is the lift, 2.46. The qmd continues with the confusion matrix, the gains chart and the uplift of the offer pilot.</a:t>
             </a:r>
           </a:p>
         </p:txBody>
@@ -2731,7 +2731,7 @@
           <a:lstStyle/>
           <a:p>
             <a:r>
-              <a:t>Work in pairs with the packages for 35 minutes, then five minutes of answers in the plenary, then ten minutes with Posit Assistant (next slide). The tasks are the “Your turn” section of logit_churn.qmd; the step numbers point to the code to reuse. Check after ten minutes that every pair has a pooled model with Germany as the reference country. Fast pairs do task 5 in the file: Step 13 with Poland as the training country. Debrief: which number would you put in a board memo, and why?</a:t>
+              <a:t>Work in pairs with the packages for 35 minutes, then five minutes of answers in the plenary, then ten minutes with Posit Assistant (next slide). The tasks are the “Your turn” section of logit_churn.qmd; the step numbers point to the code to reuse. Check after ten minutes that every pair has a pooled model with Germany as the reference country. Fast pairs do task 5 in the file: the model of Step 3 trained on Polish customers and used in every country. Debrief: which number would you put in a board memo, and why?</a:t>
             </a:r>
           </a:p>
         </p:txBody>
@@ -36161,7 +36161,7 @@
                   <a:schemeClr val="tx1"/>
                 </a:solidFill>
               </a:rPr>
-              <a:t>the AMEs with the separate country coefficients; two memo sentences (Steps 3, 4)</a:t>
+              <a:t>the AMEs with the separate country coefficients; two memo sentences (Part 3)</a:t>
             </a:r>
           </a:p>
         </p:txBody>
@@ -36301,7 +36301,7 @@
                   <a:schemeClr val="tx1"/>
                 </a:solidFill>
               </a:rPr>
-              <a:t>confusion matrix at 0.5 and top-decile lift on the 30 % test set (Steps 8, 9)</a:t>
+              <a:t>confusion matrix at 0.5 and top-decile lift on the 30 % test set (Step 3)</a:t>
             </a:r>
           </a:p>
         </p:txBody>
@@ -36441,7 +36441,7 @@
                   <a:schemeClr val="tx1"/>
                 </a:solidFill>
               </a:rPr>
-              <a:t>the offer effect by complaint calls; who should get the offer? (Step 12)</a:t>
+              <a:t>the offer effect by complaint calls; who should get the offer? (Step 4)</a:t>
             </a:r>
           </a:p>
         </p:txBody>

</xml_diff>